<commit_message>
Fix Room Migration chart using created-accounts join
Cross accounts created after July 13 with the Room Accounts Overview
by Account ID. Rebuild KPIs and cumulative plan chart from the matched
cohort, and add a segment breakdown table plus consolidated CSV export.

Co-authored-by: maiagordon-commits <maiagordon-commits@users.noreply.github.com>
</commit_message>
<xml_diff>
--- a/Room_Migration_Progress.pptx
+++ b/Room_Migration_Progress.pptx
@@ -6,6 +6,7 @@
   </p:sldMasterIdLst>
   <p:sldIdLst>
     <p:sldId id="256" r:id="rId7"/>
+    <p:sldId id="257" r:id="rId8"/>
   </p:sldIdLst>
   <p:sldSz cx="12191695" cy="6858000" type="screen4x3"/>
   <p:notesSz cx="6858000" cy="9144000"/>
@@ -3175,7 +3176,7 @@
         <p:spPr>
           <a:xfrm>
             <a:off x="502920" y="822960"/>
-            <a:ext cx="2194560" cy="347472"/>
+            <a:ext cx="2560320" cy="347472"/>
           </a:xfrm>
           <a:prstGeom prst="roundRect">
             <a:avLst>
@@ -3215,7 +3216,7 @@
                 </a:solidFill>
                 <a:latin typeface="Arial"/>
               </a:rPr>
-              <a:t>July 20 - July 24</a:t>
+              <a:t>July 13 - July 26</a:t>
             </a:r>
           </a:p>
         </p:txBody>
@@ -3228,8 +3229,8 @@
         </p:nvSpPr>
         <p:spPr>
           <a:xfrm>
-            <a:off x="4297680" y="320040"/>
-            <a:ext cx="3474720" cy="960120"/>
+            <a:off x="4114800" y="320040"/>
+            <a:ext cx="3840480" cy="960120"/>
           </a:xfrm>
           <a:prstGeom prst="roundRect">
             <a:avLst>
@@ -3269,7 +3270,7 @@
                 </a:solidFill>
                 <a:latin typeface="Arial"/>
               </a:rPr>
-              <a:t>Total Accounts Migrated</a:t>
+              <a:t>Total Accounts Created</a:t>
             </a:r>
           </a:p>
           <a:p>
@@ -3281,7 +3282,7 @@
                 </a:solidFill>
                 <a:latin typeface="Arial"/>
               </a:rPr>
-              <a:t>5</a:t>
+              <a:t>161</a:t>
             </a:r>
           </a:p>
         </p:txBody>
@@ -3347,7 +3348,7 @@
                 </a:solidFill>
                 <a:latin typeface="Arial"/>
               </a:rPr>
-              <a:t>5</a:t>
+              <a:t>156</a:t>
             </a:r>
           </a:p>
         </p:txBody>
@@ -3413,7 +3414,7 @@
                 </a:solidFill>
                 <a:latin typeface="Arial"/>
               </a:rPr>
-              <a:t>0</a:t>
+              <a:t>5</a:t>
             </a:r>
           </a:p>
           <a:p>
@@ -3520,6 +3521,707 @@
           </a:prstGeom>
         </p:spPr>
       </p:pic>
+    </p:spTree>
+  </p:cSld>
+  <p:clrMapOvr>
+    <a:masterClrMapping/>
+  </p:clrMapOvr>
+</p:sld>
+</file>
+
+<file path=ppt/slides/slide2.xml><?xml version="1.0" encoding="utf-8"?>
+<p:sld xmlns:a="http://schemas.openxmlformats.org/drawingml/2006/main" xmlns:p="http://schemas.openxmlformats.org/presentationml/2006/main" xmlns:r="http://schemas.openxmlformats.org/officeDocument/2006/relationships">
+  <p:cSld>
+    <p:spTree>
+      <p:nvGrpSpPr>
+        <p:cNvPr id="1" name=""/>
+        <p:cNvGrpSpPr/>
+        <p:nvPr/>
+      </p:nvGrpSpPr>
+      <p:grpSpPr/>
+      <p:sp>
+        <p:nvSpPr>
+          <p:cNvPr id="2" name="Rectangle 1"/>
+          <p:cNvSpPr/>
+          <p:nvPr/>
+        </p:nvSpPr>
+        <p:spPr>
+          <a:xfrm>
+            <a:off x="0" y="0"/>
+            <a:ext cx="12191695" cy="6858000"/>
+          </a:xfrm>
+          <a:prstGeom prst="rect">
+            <a:avLst/>
+          </a:prstGeom>
+          <a:solidFill>
+            <a:srgbClr val="F5F1E9"/>
+          </a:solidFill>
+          <a:ln>
+            <a:noFill/>
+          </a:ln>
+        </p:spPr>
+        <p:style>
+          <a:lnRef idx="1">
+            <a:schemeClr val="accent1"/>
+          </a:lnRef>
+          <a:fillRef idx="3">
+            <a:schemeClr val="accent1"/>
+          </a:fillRef>
+          <a:effectRef idx="2">
+            <a:schemeClr val="accent1"/>
+          </a:effectRef>
+          <a:fontRef idx="minor">
+            <a:schemeClr val="lt1"/>
+          </a:fontRef>
+        </p:style>
+        <p:txBody>
+          <a:bodyPr rtlCol="0" anchor="ctr"/>
+          <a:lstStyle/>
+          <a:p>
+            <a:pPr algn="ctr"/>
+          </a:p>
+        </p:txBody>
+      </p:sp>
+      <p:sp>
+        <p:nvSpPr>
+          <p:cNvPr id="3" name="TextBox 2"/>
+          <p:cNvSpPr txBox="1"/>
+          <p:nvPr/>
+        </p:nvSpPr>
+        <p:spPr>
+          <a:xfrm>
+            <a:off x="502920" y="320040"/>
+            <a:ext cx="10972800" cy="457200"/>
+          </a:xfrm>
+          <a:prstGeom prst="rect">
+            <a:avLst/>
+          </a:prstGeom>
+          <a:noFill/>
+        </p:spPr>
+        <p:txBody>
+          <a:bodyPr wrap="square">
+            <a:spAutoFit/>
+          </a:bodyPr>
+          <a:lstStyle/>
+          <a:p>
+            <a:pPr algn="l"/>
+            <a:r>
+              <a:rPr sz="2600" b="1">
+                <a:solidFill>
+                  <a:srgbClr val="1B3A5F"/>
+                </a:solidFill>
+                <a:latin typeface="Arial"/>
+              </a:rPr>
+              <a:t>Accounts Created After July 13 — Segment Breakdown</a:t>
+            </a:r>
+          </a:p>
+        </p:txBody>
+      </p:sp>
+      <p:sp>
+        <p:nvSpPr>
+          <p:cNvPr id="4" name="TextBox 3"/>
+          <p:cNvSpPr txBox="1"/>
+          <p:nvPr/>
+        </p:nvSpPr>
+        <p:spPr>
+          <a:xfrm>
+            <a:off x="502920" y="868680"/>
+            <a:ext cx="10972800" cy="365760"/>
+          </a:xfrm>
+          <a:prstGeom prst="rect">
+            <a:avLst/>
+          </a:prstGeom>
+          <a:noFill/>
+        </p:spPr>
+        <p:txBody>
+          <a:bodyPr wrap="square">
+            <a:spAutoFit/>
+          </a:bodyPr>
+          <a:lstStyle/>
+          <a:p>
+            <a:pPr algn="l"/>
+            <a:r>
+              <a:rPr sz="1400" b="0">
+                <a:solidFill>
+                  <a:srgbClr val="6B7C93"/>
+                </a:solidFill>
+                <a:latin typeface="Arial"/>
+              </a:rPr>
+              <a:t>Matched room accounts: 161  ·  July 13 - July 26</a:t>
+            </a:r>
+          </a:p>
+        </p:txBody>
+      </p:sp>
+      <p:sp>
+        <p:nvSpPr>
+          <p:cNvPr id="5" name="Rounded Rectangle 4"/>
+          <p:cNvSpPr/>
+          <p:nvPr/>
+        </p:nvSpPr>
+        <p:spPr>
+          <a:xfrm>
+            <a:off x="502920" y="1463040"/>
+            <a:ext cx="11155680" cy="457200"/>
+          </a:xfrm>
+          <a:prstGeom prst="roundRect">
+            <a:avLst>
+              <a:gd name="adj" fmla="val 12000"/>
+            </a:avLst>
+          </a:prstGeom>
+          <a:solidFill>
+            <a:srgbClr val="D9EAF7"/>
+          </a:solidFill>
+          <a:ln>
+            <a:noFill/>
+          </a:ln>
+        </p:spPr>
+        <p:style>
+          <a:lnRef idx="1">
+            <a:schemeClr val="accent1"/>
+          </a:lnRef>
+          <a:fillRef idx="3">
+            <a:schemeClr val="accent1"/>
+          </a:fillRef>
+          <a:effectRef idx="2">
+            <a:schemeClr val="accent1"/>
+          </a:effectRef>
+          <a:fontRef idx="minor">
+            <a:schemeClr val="lt1"/>
+          </a:fontRef>
+        </p:style>
+        <p:txBody>
+          <a:bodyPr rtlCol="0" anchor="ctr"/>
+          <a:lstStyle/>
+          <a:p>
+            <a:pPr algn="ctr"/>
+          </a:p>
+        </p:txBody>
+      </p:sp>
+      <p:sp>
+        <p:nvSpPr>
+          <p:cNvPr id="6" name="TextBox 5"/>
+          <p:cNvSpPr txBox="1"/>
+          <p:nvPr/>
+        </p:nvSpPr>
+        <p:spPr>
+          <a:xfrm>
+            <a:off x="640080" y="1536192"/>
+            <a:ext cx="2743200" cy="320040"/>
+          </a:xfrm>
+          <a:prstGeom prst="rect">
+            <a:avLst/>
+          </a:prstGeom>
+          <a:noFill/>
+        </p:spPr>
+        <p:txBody>
+          <a:bodyPr wrap="square">
+            <a:spAutoFit/>
+          </a:bodyPr>
+          <a:lstStyle/>
+          <a:p>
+            <a:pPr algn="l"/>
+            <a:r>
+              <a:rPr sz="1400" b="1">
+                <a:solidFill>
+                  <a:srgbClr val="1B3A5F"/>
+                </a:solidFill>
+                <a:latin typeface="Arial"/>
+              </a:rPr>
+              <a:t>Segment</a:t>
+            </a:r>
+          </a:p>
+        </p:txBody>
+      </p:sp>
+      <p:sp>
+        <p:nvSpPr>
+          <p:cNvPr id="7" name="TextBox 6"/>
+          <p:cNvSpPr txBox="1"/>
+          <p:nvPr/>
+        </p:nvSpPr>
+        <p:spPr>
+          <a:xfrm>
+            <a:off x="3840480" y="1536192"/>
+            <a:ext cx="1371600" cy="320040"/>
+          </a:xfrm>
+          <a:prstGeom prst="rect">
+            <a:avLst/>
+          </a:prstGeom>
+          <a:noFill/>
+        </p:spPr>
+        <p:txBody>
+          <a:bodyPr wrap="square">
+            <a:spAutoFit/>
+          </a:bodyPr>
+          <a:lstStyle/>
+          <a:p>
+            <a:pPr algn="l"/>
+            <a:r>
+              <a:rPr sz="1400" b="1">
+                <a:solidFill>
+                  <a:srgbClr val="1B3A5F"/>
+                </a:solidFill>
+                <a:latin typeface="Arial"/>
+              </a:rPr>
+              <a:t>Total</a:t>
+            </a:r>
+          </a:p>
+        </p:txBody>
+      </p:sp>
+      <p:sp>
+        <p:nvSpPr>
+          <p:cNvPr id="8" name="TextBox 7"/>
+          <p:cNvSpPr txBox="1"/>
+          <p:nvPr/>
+        </p:nvSpPr>
+        <p:spPr>
+          <a:xfrm>
+            <a:off x="5486400" y="1536192"/>
+            <a:ext cx="1371600" cy="320040"/>
+          </a:xfrm>
+          <a:prstGeom prst="rect">
+            <a:avLst/>
+          </a:prstGeom>
+          <a:noFill/>
+        </p:spPr>
+        <p:txBody>
+          <a:bodyPr wrap="square">
+            <a:spAutoFit/>
+          </a:bodyPr>
+          <a:lstStyle/>
+          <a:p>
+            <a:pPr algn="l"/>
+            <a:r>
+              <a:rPr sz="1400" b="1">
+                <a:solidFill>
+                  <a:srgbClr val="1B3A5F"/>
+                </a:solidFill>
+                <a:latin typeface="Arial"/>
+              </a:rPr>
+              <a:t>Lite</a:t>
+            </a:r>
+          </a:p>
+        </p:txBody>
+      </p:sp>
+      <p:sp>
+        <p:nvSpPr>
+          <p:cNvPr id="9" name="TextBox 8"/>
+          <p:cNvSpPr txBox="1"/>
+          <p:nvPr/>
+        </p:nvSpPr>
+        <p:spPr>
+          <a:xfrm>
+            <a:off x="7132320" y="1536192"/>
+            <a:ext cx="1371600" cy="320040"/>
+          </a:xfrm>
+          <a:prstGeom prst="rect">
+            <a:avLst/>
+          </a:prstGeom>
+          <a:noFill/>
+        </p:spPr>
+        <p:txBody>
+          <a:bodyPr wrap="square">
+            <a:spAutoFit/>
+          </a:bodyPr>
+          <a:lstStyle/>
+          <a:p>
+            <a:pPr algn="l"/>
+            <a:r>
+              <a:rPr sz="1400" b="1">
+                <a:solidFill>
+                  <a:srgbClr val="1B3A5F"/>
+                </a:solidFill>
+                <a:latin typeface="Arial"/>
+              </a:rPr>
+              <a:t>Pro</a:t>
+            </a:r>
+          </a:p>
+        </p:txBody>
+      </p:sp>
+      <p:sp>
+        <p:nvSpPr>
+          <p:cNvPr id="10" name="TextBox 9"/>
+          <p:cNvSpPr txBox="1"/>
+          <p:nvPr/>
+        </p:nvSpPr>
+        <p:spPr>
+          <a:xfrm>
+            <a:off x="8778240" y="1536192"/>
+            <a:ext cx="1645920" cy="320040"/>
+          </a:xfrm>
+          <a:prstGeom prst="rect">
+            <a:avLst/>
+          </a:prstGeom>
+          <a:noFill/>
+        </p:spPr>
+        <p:txBody>
+          <a:bodyPr wrap="square">
+            <a:spAutoFit/>
+          </a:bodyPr>
+          <a:lstStyle/>
+          <a:p>
+            <a:pPr algn="l"/>
+            <a:r>
+              <a:rPr sz="1400" b="1">
+                <a:solidFill>
+                  <a:srgbClr val="1B3A5F"/>
+                </a:solidFill>
+                <a:latin typeface="Arial"/>
+              </a:rPr>
+              <a:t>Enterprise</a:t>
+            </a:r>
+          </a:p>
+        </p:txBody>
+      </p:sp>
+      <p:sp>
+        <p:nvSpPr>
+          <p:cNvPr id="11" name="TextBox 10"/>
+          <p:cNvSpPr txBox="1"/>
+          <p:nvPr/>
+        </p:nvSpPr>
+        <p:spPr>
+          <a:xfrm>
+            <a:off x="640080" y="2057400"/>
+            <a:ext cx="2743200" cy="320040"/>
+          </a:xfrm>
+          <a:prstGeom prst="rect">
+            <a:avLst/>
+          </a:prstGeom>
+          <a:noFill/>
+        </p:spPr>
+        <p:txBody>
+          <a:bodyPr wrap="square">
+            <a:spAutoFit/>
+          </a:bodyPr>
+          <a:lstStyle/>
+          <a:p>
+            <a:pPr algn="l"/>
+            <a:r>
+              <a:rPr sz="1400" b="0">
+                <a:solidFill>
+                  <a:srgbClr val="1B3A5F"/>
+                </a:solidFill>
+                <a:latin typeface="Arial"/>
+              </a:rPr>
+              <a:t>SMB</a:t>
+            </a:r>
+          </a:p>
+        </p:txBody>
+      </p:sp>
+      <p:sp>
+        <p:nvSpPr>
+          <p:cNvPr id="12" name="TextBox 11"/>
+          <p:cNvSpPr txBox="1"/>
+          <p:nvPr/>
+        </p:nvSpPr>
+        <p:spPr>
+          <a:xfrm>
+            <a:off x="3840480" y="2057400"/>
+            <a:ext cx="1371600" cy="320040"/>
+          </a:xfrm>
+          <a:prstGeom prst="rect">
+            <a:avLst/>
+          </a:prstGeom>
+          <a:noFill/>
+        </p:spPr>
+        <p:txBody>
+          <a:bodyPr wrap="square">
+            <a:spAutoFit/>
+          </a:bodyPr>
+          <a:lstStyle/>
+          <a:p>
+            <a:pPr algn="l"/>
+            <a:r>
+              <a:rPr sz="1400" b="1">
+                <a:solidFill>
+                  <a:srgbClr val="1B3A5F"/>
+                </a:solidFill>
+                <a:latin typeface="Arial"/>
+              </a:rPr>
+              <a:t>161</a:t>
+            </a:r>
+          </a:p>
+        </p:txBody>
+      </p:sp>
+      <p:sp>
+        <p:nvSpPr>
+          <p:cNvPr id="13" name="TextBox 12"/>
+          <p:cNvSpPr txBox="1"/>
+          <p:nvPr/>
+        </p:nvSpPr>
+        <p:spPr>
+          <a:xfrm>
+            <a:off x="5486400" y="2057400"/>
+            <a:ext cx="1371600" cy="320040"/>
+          </a:xfrm>
+          <a:prstGeom prst="rect">
+            <a:avLst/>
+          </a:prstGeom>
+          <a:noFill/>
+        </p:spPr>
+        <p:txBody>
+          <a:bodyPr wrap="square">
+            <a:spAutoFit/>
+          </a:bodyPr>
+          <a:lstStyle/>
+          <a:p>
+            <a:pPr algn="l"/>
+            <a:r>
+              <a:rPr sz="1400" b="0">
+                <a:solidFill>
+                  <a:srgbClr val="1B3A5F"/>
+                </a:solidFill>
+                <a:latin typeface="Arial"/>
+              </a:rPr>
+              <a:t>156</a:t>
+            </a:r>
+          </a:p>
+        </p:txBody>
+      </p:sp>
+      <p:sp>
+        <p:nvSpPr>
+          <p:cNvPr id="14" name="TextBox 13"/>
+          <p:cNvSpPr txBox="1"/>
+          <p:nvPr/>
+        </p:nvSpPr>
+        <p:spPr>
+          <a:xfrm>
+            <a:off x="7132320" y="2057400"/>
+            <a:ext cx="1371600" cy="320040"/>
+          </a:xfrm>
+          <a:prstGeom prst="rect">
+            <a:avLst/>
+          </a:prstGeom>
+          <a:noFill/>
+        </p:spPr>
+        <p:txBody>
+          <a:bodyPr wrap="square">
+            <a:spAutoFit/>
+          </a:bodyPr>
+          <a:lstStyle/>
+          <a:p>
+            <a:pPr algn="l"/>
+            <a:r>
+              <a:rPr sz="1400" b="0">
+                <a:solidFill>
+                  <a:srgbClr val="1B3A5F"/>
+                </a:solidFill>
+                <a:latin typeface="Arial"/>
+              </a:rPr>
+              <a:t>5</a:t>
+            </a:r>
+          </a:p>
+        </p:txBody>
+      </p:sp>
+      <p:sp>
+        <p:nvSpPr>
+          <p:cNvPr id="15" name="TextBox 14"/>
+          <p:cNvSpPr txBox="1"/>
+          <p:nvPr/>
+        </p:nvSpPr>
+        <p:spPr>
+          <a:xfrm>
+            <a:off x="8778240" y="2057400"/>
+            <a:ext cx="1645920" cy="320040"/>
+          </a:xfrm>
+          <a:prstGeom prst="rect">
+            <a:avLst/>
+          </a:prstGeom>
+          <a:noFill/>
+        </p:spPr>
+        <p:txBody>
+          <a:bodyPr wrap="square">
+            <a:spAutoFit/>
+          </a:bodyPr>
+          <a:lstStyle/>
+          <a:p>
+            <a:pPr algn="l"/>
+            <a:r>
+              <a:rPr sz="1400" b="0">
+                <a:solidFill>
+                  <a:srgbClr val="1B3A5F"/>
+                </a:solidFill>
+                <a:latin typeface="Arial"/>
+              </a:rPr>
+              <a:t>0</a:t>
+            </a:r>
+          </a:p>
+        </p:txBody>
+      </p:sp>
+      <p:sp>
+        <p:nvSpPr>
+          <p:cNvPr id="16" name="TextBox 15"/>
+          <p:cNvSpPr txBox="1"/>
+          <p:nvPr/>
+        </p:nvSpPr>
+        <p:spPr>
+          <a:xfrm>
+            <a:off x="640080" y="2651760"/>
+            <a:ext cx="2743200" cy="320040"/>
+          </a:xfrm>
+          <a:prstGeom prst="rect">
+            <a:avLst/>
+          </a:prstGeom>
+          <a:noFill/>
+        </p:spPr>
+        <p:txBody>
+          <a:bodyPr wrap="square">
+            <a:spAutoFit/>
+          </a:bodyPr>
+          <a:lstStyle/>
+          <a:p>
+            <a:pPr algn="l"/>
+            <a:r>
+              <a:rPr sz="1400" b="1">
+                <a:solidFill>
+                  <a:srgbClr val="1B3A5F"/>
+                </a:solidFill>
+                <a:latin typeface="Arial"/>
+              </a:rPr>
+              <a:t>TOTAL</a:t>
+            </a:r>
+          </a:p>
+        </p:txBody>
+      </p:sp>
+      <p:sp>
+        <p:nvSpPr>
+          <p:cNvPr id="17" name="TextBox 16"/>
+          <p:cNvSpPr txBox="1"/>
+          <p:nvPr/>
+        </p:nvSpPr>
+        <p:spPr>
+          <a:xfrm>
+            <a:off x="3840480" y="2651760"/>
+            <a:ext cx="1371600" cy="320040"/>
+          </a:xfrm>
+          <a:prstGeom prst="rect">
+            <a:avLst/>
+          </a:prstGeom>
+          <a:noFill/>
+        </p:spPr>
+        <p:txBody>
+          <a:bodyPr wrap="square">
+            <a:spAutoFit/>
+          </a:bodyPr>
+          <a:lstStyle/>
+          <a:p>
+            <a:pPr algn="l"/>
+            <a:r>
+              <a:rPr sz="1400" b="1">
+                <a:solidFill>
+                  <a:srgbClr val="1B3A5F"/>
+                </a:solidFill>
+                <a:latin typeface="Arial"/>
+              </a:rPr>
+              <a:t>161</a:t>
+            </a:r>
+          </a:p>
+        </p:txBody>
+      </p:sp>
+      <p:sp>
+        <p:nvSpPr>
+          <p:cNvPr id="18" name="TextBox 17"/>
+          <p:cNvSpPr txBox="1"/>
+          <p:nvPr/>
+        </p:nvSpPr>
+        <p:spPr>
+          <a:xfrm>
+            <a:off x="5486400" y="2651760"/>
+            <a:ext cx="1371600" cy="320040"/>
+          </a:xfrm>
+          <a:prstGeom prst="rect">
+            <a:avLst/>
+          </a:prstGeom>
+          <a:noFill/>
+        </p:spPr>
+        <p:txBody>
+          <a:bodyPr wrap="square">
+            <a:spAutoFit/>
+          </a:bodyPr>
+          <a:lstStyle/>
+          <a:p>
+            <a:pPr algn="l"/>
+            <a:r>
+              <a:rPr sz="1400" b="1">
+                <a:solidFill>
+                  <a:srgbClr val="1B3A5F"/>
+                </a:solidFill>
+                <a:latin typeface="Arial"/>
+              </a:rPr>
+              <a:t>156</a:t>
+            </a:r>
+          </a:p>
+        </p:txBody>
+      </p:sp>
+      <p:sp>
+        <p:nvSpPr>
+          <p:cNvPr id="19" name="TextBox 18"/>
+          <p:cNvSpPr txBox="1"/>
+          <p:nvPr/>
+        </p:nvSpPr>
+        <p:spPr>
+          <a:xfrm>
+            <a:off x="7132320" y="2651760"/>
+            <a:ext cx="1371600" cy="320040"/>
+          </a:xfrm>
+          <a:prstGeom prst="rect">
+            <a:avLst/>
+          </a:prstGeom>
+          <a:noFill/>
+        </p:spPr>
+        <p:txBody>
+          <a:bodyPr wrap="square">
+            <a:spAutoFit/>
+          </a:bodyPr>
+          <a:lstStyle/>
+          <a:p>
+            <a:pPr algn="l"/>
+            <a:r>
+              <a:rPr sz="1400" b="1">
+                <a:solidFill>
+                  <a:srgbClr val="1B3A5F"/>
+                </a:solidFill>
+                <a:latin typeface="Arial"/>
+              </a:rPr>
+              <a:t>5</a:t>
+            </a:r>
+          </a:p>
+        </p:txBody>
+      </p:sp>
+      <p:sp>
+        <p:nvSpPr>
+          <p:cNvPr id="20" name="TextBox 19"/>
+          <p:cNvSpPr txBox="1"/>
+          <p:nvPr/>
+        </p:nvSpPr>
+        <p:spPr>
+          <a:xfrm>
+            <a:off x="8778240" y="2651760"/>
+            <a:ext cx="1645920" cy="320040"/>
+          </a:xfrm>
+          <a:prstGeom prst="rect">
+            <a:avLst/>
+          </a:prstGeom>
+          <a:noFill/>
+        </p:spPr>
+        <p:txBody>
+          <a:bodyPr wrap="square">
+            <a:spAutoFit/>
+          </a:bodyPr>
+          <a:lstStyle/>
+          <a:p>
+            <a:pPr algn="l"/>
+            <a:r>
+              <a:rPr sz="1400" b="1">
+                <a:solidFill>
+                  <a:srgbClr val="1B3A5F"/>
+                </a:solidFill>
+                <a:latin typeface="Arial"/>
+              </a:rPr>
+              <a:t>0</a:t>
+            </a:r>
+          </a:p>
+        </p:txBody>
+      </p:sp>
     </p:spTree>
   </p:cSld>
   <p:clrMapOvr>

</xml_diff>

<commit_message>
Use all created accounts; left-join Room Overview
Keep the full ~2,876 created-after-July-13 accounts as the chart
universe. Attach Package/Segment only when the Account ID exists in
the Room Overview (161 matched); the rest are Not in Room Overview.

Co-authored-by: maiagordon-commits <maiagordon-commits@users.noreply.github.com>
</commit_message>
<xml_diff>
--- a/Room_Migration_Progress.pptx
+++ b/Room_Migration_Progress.pptx
@@ -3216,7 +3216,7 @@
                 </a:solidFill>
                 <a:latin typeface="Arial"/>
               </a:rPr>
-              <a:t>July 13 - July 26</a:t>
+              <a:t>July 13 - July 27</a:t>
             </a:r>
           </a:p>
         </p:txBody>
@@ -3229,8 +3229,8 @@
         </p:nvSpPr>
         <p:spPr>
           <a:xfrm>
-            <a:off x="4114800" y="320040"/>
-            <a:ext cx="3840480" cy="960120"/>
+            <a:off x="4114800" y="274320"/>
+            <a:ext cx="3840480" cy="914400"/>
           </a:xfrm>
           <a:prstGeom prst="roundRect">
             <a:avLst>
@@ -3264,7 +3264,7 @@
           <a:p>
             <a:pPr algn="ctr"/>
             <a:r>
-              <a:rPr sz="1200" b="0">
+              <a:rPr sz="1100" b="0">
                 <a:solidFill>
                   <a:srgbClr val="1B3A5F"/>
                 </a:solidFill>
@@ -3276,13 +3276,13 @@
           <a:p>
             <a:pPr algn="ctr"/>
             <a:r>
-              <a:rPr sz="2800" b="1">
+              <a:rPr sz="2600" b="1">
                 <a:solidFill>
                   <a:srgbClr val="1B3A5F"/>
                 </a:solidFill>
                 <a:latin typeface="Arial"/>
               </a:rPr>
-              <a:t>161</a:t>
+              <a:t>2,876</a:t>
             </a:r>
           </a:p>
         </p:txBody>
@@ -3295,8 +3295,8 @@
         </p:nvSpPr>
         <p:spPr>
           <a:xfrm>
-            <a:off x="1371600" y="1417320"/>
-            <a:ext cx="2926080" cy="1005840"/>
+            <a:off x="502920" y="1371600"/>
+            <a:ext cx="2651760" cy="960120"/>
           </a:xfrm>
           <a:prstGeom prst="roundRect">
             <a:avLst>
@@ -3330,7 +3330,7 @@
           <a:p>
             <a:pPr algn="ctr"/>
             <a:r>
-              <a:rPr sz="1200" b="0">
+              <a:rPr sz="1100" b="0">
                 <a:solidFill>
                   <a:srgbClr val="1B3A5F"/>
                 </a:solidFill>
@@ -3342,7 +3342,7 @@
           <a:p>
             <a:pPr algn="ctr"/>
             <a:r>
-              <a:rPr sz="2800" b="1">
+              <a:rPr sz="2600" b="1">
                 <a:solidFill>
                   <a:srgbClr val="1B3A5F"/>
                 </a:solidFill>
@@ -3361,8 +3361,8 @@
         </p:nvSpPr>
         <p:spPr>
           <a:xfrm>
-            <a:off x="4617720" y="1417320"/>
-            <a:ext cx="2926080" cy="1005840"/>
+            <a:off x="3337560" y="1371600"/>
+            <a:ext cx="2651760" cy="960120"/>
           </a:xfrm>
           <a:prstGeom prst="roundRect">
             <a:avLst>
@@ -3396,7 +3396,7 @@
           <a:p>
             <a:pPr algn="ctr"/>
             <a:r>
-              <a:rPr sz="1200" b="0">
+              <a:rPr sz="1100" b="0">
                 <a:solidFill>
                   <a:srgbClr val="1B3A5F"/>
                 </a:solidFill>
@@ -3408,7 +3408,7 @@
           <a:p>
             <a:pPr algn="ctr"/>
             <a:r>
-              <a:rPr sz="2800" b="1">
+              <a:rPr sz="2600" b="1">
                 <a:solidFill>
                   <a:srgbClr val="1B3A5F"/>
                 </a:solidFill>
@@ -3420,7 +3420,7 @@
           <a:p>
             <a:pPr algn="ctr"/>
             <a:r>
-              <a:rPr sz="1000" b="0">
+              <a:rPr sz="900" b="0">
                 <a:solidFill>
                   <a:srgbClr val="6B7C93"/>
                 </a:solidFill>
@@ -3439,8 +3439,8 @@
         </p:nvSpPr>
         <p:spPr>
           <a:xfrm>
-            <a:off x="7863840" y="1417320"/>
-            <a:ext cx="2926080" cy="1005840"/>
+            <a:off x="6172200" y="1371600"/>
+            <a:ext cx="2651760" cy="960120"/>
           </a:xfrm>
           <a:prstGeom prst="roundRect">
             <a:avLst>
@@ -3474,7 +3474,7 @@
           <a:p>
             <a:pPr algn="ctr"/>
             <a:r>
-              <a:rPr sz="1200" b="0">
+              <a:rPr sz="1100" b="0">
                 <a:solidFill>
                   <a:srgbClr val="1B3A5F"/>
                 </a:solidFill>
@@ -3486,7 +3486,7 @@
           <a:p>
             <a:pPr algn="ctr"/>
             <a:r>
-              <a:rPr sz="2800" b="1">
+              <a:rPr sz="2600" b="1">
                 <a:solidFill>
                   <a:srgbClr val="1B3A5F"/>
                 </a:solidFill>
@@ -3497,9 +3497,87 @@
           </a:p>
         </p:txBody>
       </p:sp>
+      <p:sp>
+        <p:nvSpPr>
+          <p:cNvPr id="9" name="Rounded Rectangle 8"/>
+          <p:cNvSpPr/>
+          <p:nvPr/>
+        </p:nvSpPr>
+        <p:spPr>
+          <a:xfrm>
+            <a:off x="9006840" y="1371600"/>
+            <a:ext cx="2651760" cy="960120"/>
+          </a:xfrm>
+          <a:prstGeom prst="roundRect">
+            <a:avLst>
+              <a:gd name="adj" fmla="val 12000"/>
+            </a:avLst>
+          </a:prstGeom>
+          <a:solidFill>
+            <a:srgbClr val="D9EAF7"/>
+          </a:solidFill>
+          <a:ln>
+            <a:noFill/>
+          </a:ln>
+        </p:spPr>
+        <p:style>
+          <a:lnRef idx="1">
+            <a:schemeClr val="accent1"/>
+          </a:lnRef>
+          <a:fillRef idx="3">
+            <a:schemeClr val="accent1"/>
+          </a:fillRef>
+          <a:effectRef idx="2">
+            <a:schemeClr val="accent1"/>
+          </a:effectRef>
+          <a:fontRef idx="minor">
+            <a:schemeClr val="lt1"/>
+          </a:fontRef>
+        </p:style>
+        <p:txBody>
+          <a:bodyPr rtlCol="0" anchor="ctr" wrap="square"/>
+          <a:lstStyle/>
+          <a:p>
+            <a:pPr algn="ctr"/>
+            <a:r>
+              <a:rPr sz="1100" b="0">
+                <a:solidFill>
+                  <a:srgbClr val="1B3A5F"/>
+                </a:solidFill>
+                <a:latin typeface="Arial"/>
+              </a:rPr>
+              <a:t>Not in Room Overview</a:t>
+            </a:r>
+          </a:p>
+          <a:p>
+            <a:pPr algn="ctr"/>
+            <a:r>
+              <a:rPr sz="2200" b="1">
+                <a:solidFill>
+                  <a:srgbClr val="1B3A5F"/>
+                </a:solidFill>
+                <a:latin typeface="Arial"/>
+              </a:rPr>
+              <a:t>2,715</a:t>
+            </a:r>
+          </a:p>
+          <a:p>
+            <a:pPr algn="ctr"/>
+            <a:r>
+              <a:rPr sz="900" b="0">
+                <a:solidFill>
+                  <a:srgbClr val="6B7C93"/>
+                </a:solidFill>
+                <a:latin typeface="Arial"/>
+              </a:rPr>
+              <a:t>161 matched</a:t>
+            </a:r>
+          </a:p>
+        </p:txBody>
+      </p:sp>
       <p:pic>
         <p:nvPicPr>
-          <p:cNvPr id="9" name="Picture 8" descr="room-migration-chart.png"/>
+          <p:cNvPr id="10" name="Picture 9" descr="room-migration-chart.png"/>
           <p:cNvPicPr>
             <a:picLocks noChangeAspect="1"/>
           </p:cNvPicPr>
@@ -3513,7 +3591,7 @@
         </p:blipFill>
         <p:spPr>
           <a:xfrm>
-            <a:off x="502920" y="2651760"/>
+            <a:off x="502920" y="2606040"/>
             <a:ext cx="11155680" cy="3657600"/>
           </a:xfrm>
           <a:prstGeom prst="rect">
@@ -3626,7 +3704,7 @@
         <p:spPr>
           <a:xfrm>
             <a:off x="502920" y="868680"/>
-            <a:ext cx="10972800" cy="365760"/>
+            <a:ext cx="10972800" cy="411480"/>
           </a:xfrm>
           <a:prstGeom prst="rect">
             <a:avLst/>
@@ -3641,13 +3719,13 @@
           <a:p>
             <a:pPr algn="l"/>
             <a:r>
-              <a:rPr sz="1400" b="0">
+              <a:rPr sz="1300" b="0">
                 <a:solidFill>
                   <a:srgbClr val="6B7C93"/>
                 </a:solidFill>
                 <a:latin typeface="Arial"/>
               </a:rPr>
-              <a:t>Matched room accounts: 161  ·  July 13 - July 26</a:t>
+              <a:t>All created accounts: 2,876  ·  Found in Room Overview (Package/Segment available): 161  ·  Not in Room Overview: 2,715</a:t>
             </a:r>
           </a:p>
         </p:txBody>
@@ -3706,7 +3784,7 @@
         <p:spPr>
           <a:xfrm>
             <a:off x="640080" y="1536192"/>
-            <a:ext cx="2743200" cy="320040"/>
+            <a:ext cx="1645920" cy="320040"/>
           </a:xfrm>
           <a:prstGeom prst="rect">
             <a:avLst/>
@@ -3721,7 +3799,7 @@
           <a:p>
             <a:pPr algn="l"/>
             <a:r>
-              <a:rPr sz="1400" b="1">
+              <a:rPr sz="1300" b="1">
                 <a:solidFill>
                   <a:srgbClr val="1B3A5F"/>
                 </a:solidFill>
@@ -3740,8 +3818,8 @@
         </p:nvSpPr>
         <p:spPr>
           <a:xfrm>
-            <a:off x="3840480" y="1536192"/>
-            <a:ext cx="1371600" cy="320040"/>
+            <a:off x="3657600" y="1536192"/>
+            <a:ext cx="1645920" cy="320040"/>
           </a:xfrm>
           <a:prstGeom prst="rect">
             <a:avLst/>
@@ -3756,7 +3834,7 @@
           <a:p>
             <a:pPr algn="l"/>
             <a:r>
-              <a:rPr sz="1400" b="1">
+              <a:rPr sz="1300" b="1">
                 <a:solidFill>
                   <a:srgbClr val="1B3A5F"/>
                 </a:solidFill>
@@ -3775,8 +3853,8 @@
         </p:nvSpPr>
         <p:spPr>
           <a:xfrm>
-            <a:off x="5486400" y="1536192"/>
-            <a:ext cx="1371600" cy="320040"/>
+            <a:off x="5303520" y="1536192"/>
+            <a:ext cx="1645920" cy="320040"/>
           </a:xfrm>
           <a:prstGeom prst="rect">
             <a:avLst/>
@@ -3791,7 +3869,7 @@
           <a:p>
             <a:pPr algn="l"/>
             <a:r>
-              <a:rPr sz="1400" b="1">
+              <a:rPr sz="1300" b="1">
                 <a:solidFill>
                   <a:srgbClr val="1B3A5F"/>
                 </a:solidFill>
@@ -3810,8 +3888,8 @@
         </p:nvSpPr>
         <p:spPr>
           <a:xfrm>
-            <a:off x="7132320" y="1536192"/>
-            <a:ext cx="1371600" cy="320040"/>
+            <a:off x="6858000" y="1536192"/>
+            <a:ext cx="1645920" cy="320040"/>
           </a:xfrm>
           <a:prstGeom prst="rect">
             <a:avLst/>
@@ -3826,7 +3904,7 @@
           <a:p>
             <a:pPr algn="l"/>
             <a:r>
-              <a:rPr sz="1400" b="1">
+              <a:rPr sz="1300" b="1">
                 <a:solidFill>
                   <a:srgbClr val="1B3A5F"/>
                 </a:solidFill>
@@ -3845,7 +3923,7 @@
         </p:nvSpPr>
         <p:spPr>
           <a:xfrm>
-            <a:off x="8778240" y="1536192"/>
+            <a:off x="8229600" y="1536192"/>
             <a:ext cx="1645920" cy="320040"/>
           </a:xfrm>
           <a:prstGeom prst="rect">
@@ -3861,7 +3939,7 @@
           <a:p>
             <a:pPr algn="l"/>
             <a:r>
-              <a:rPr sz="1400" b="1">
+              <a:rPr sz="1300" b="1">
                 <a:solidFill>
                   <a:srgbClr val="1B3A5F"/>
                 </a:solidFill>
@@ -3880,8 +3958,8 @@
         </p:nvSpPr>
         <p:spPr>
           <a:xfrm>
-            <a:off x="640080" y="2057400"/>
-            <a:ext cx="2743200" cy="320040"/>
+            <a:off x="9784080" y="1536192"/>
+            <a:ext cx="1645920" cy="320040"/>
           </a:xfrm>
           <a:prstGeom prst="rect">
             <a:avLst/>
@@ -3896,13 +3974,13 @@
           <a:p>
             <a:pPr algn="l"/>
             <a:r>
-              <a:rPr sz="1400" b="0">
+              <a:rPr sz="1300" b="1">
                 <a:solidFill>
                   <a:srgbClr val="1B3A5F"/>
                 </a:solidFill>
                 <a:latin typeface="Arial"/>
               </a:rPr>
-              <a:t>SMB</a:t>
+              <a:t>Not in Room</a:t>
             </a:r>
           </a:p>
         </p:txBody>
@@ -3915,8 +3993,8 @@
         </p:nvSpPr>
         <p:spPr>
           <a:xfrm>
-            <a:off x="3840480" y="2057400"/>
-            <a:ext cx="1371600" cy="320040"/>
+            <a:off x="640080" y="2057400"/>
+            <a:ext cx="2926080" cy="320040"/>
           </a:xfrm>
           <a:prstGeom prst="rect">
             <a:avLst/>
@@ -3931,13 +4009,13 @@
           <a:p>
             <a:pPr algn="l"/>
             <a:r>
-              <a:rPr sz="1400" b="1">
+              <a:rPr sz="1300" b="0">
                 <a:solidFill>
                   <a:srgbClr val="1B3A5F"/>
                 </a:solidFill>
                 <a:latin typeface="Arial"/>
               </a:rPr>
-              <a:t>161</a:t>
+              <a:t>Not in Room Overview</a:t>
             </a:r>
           </a:p>
         </p:txBody>
@@ -3950,7 +4028,7 @@
         </p:nvSpPr>
         <p:spPr>
           <a:xfrm>
-            <a:off x="5486400" y="2057400"/>
+            <a:off x="3657600" y="2057400"/>
             <a:ext cx="1371600" cy="320040"/>
           </a:xfrm>
           <a:prstGeom prst="rect">
@@ -3966,13 +4044,13 @@
           <a:p>
             <a:pPr algn="l"/>
             <a:r>
-              <a:rPr sz="1400" b="0">
+              <a:rPr sz="1300" b="1">
                 <a:solidFill>
                   <a:srgbClr val="1B3A5F"/>
                 </a:solidFill>
                 <a:latin typeface="Arial"/>
               </a:rPr>
-              <a:t>156</a:t>
+              <a:t>2,715</a:t>
             </a:r>
           </a:p>
         </p:txBody>
@@ -3985,8 +4063,8 @@
         </p:nvSpPr>
         <p:spPr>
           <a:xfrm>
-            <a:off x="7132320" y="2057400"/>
-            <a:ext cx="1371600" cy="320040"/>
+            <a:off x="5303520" y="2057400"/>
+            <a:ext cx="1280160" cy="320040"/>
           </a:xfrm>
           <a:prstGeom prst="rect">
             <a:avLst/>
@@ -4001,13 +4079,13 @@
           <a:p>
             <a:pPr algn="l"/>
             <a:r>
-              <a:rPr sz="1400" b="0">
+              <a:rPr sz="1300" b="0">
                 <a:solidFill>
                   <a:srgbClr val="1B3A5F"/>
                 </a:solidFill>
                 <a:latin typeface="Arial"/>
               </a:rPr>
-              <a:t>5</a:t>
+              <a:t>0</a:t>
             </a:r>
           </a:p>
         </p:txBody>
@@ -4020,8 +4098,8 @@
         </p:nvSpPr>
         <p:spPr>
           <a:xfrm>
-            <a:off x="8778240" y="2057400"/>
-            <a:ext cx="1645920" cy="320040"/>
+            <a:off x="6858000" y="2057400"/>
+            <a:ext cx="1280160" cy="320040"/>
           </a:xfrm>
           <a:prstGeom prst="rect">
             <a:avLst/>
@@ -4036,7 +4114,7 @@
           <a:p>
             <a:pPr algn="l"/>
             <a:r>
-              <a:rPr sz="1400" b="0">
+              <a:rPr sz="1300" b="0">
                 <a:solidFill>
                   <a:srgbClr val="1B3A5F"/>
                 </a:solidFill>
@@ -4055,8 +4133,8 @@
         </p:nvSpPr>
         <p:spPr>
           <a:xfrm>
-            <a:off x="640080" y="2651760"/>
-            <a:ext cx="2743200" cy="320040"/>
+            <a:off x="8229600" y="2057400"/>
+            <a:ext cx="1280160" cy="320040"/>
           </a:xfrm>
           <a:prstGeom prst="rect">
             <a:avLst/>
@@ -4071,13 +4149,13 @@
           <a:p>
             <a:pPr algn="l"/>
             <a:r>
-              <a:rPr sz="1400" b="1">
+              <a:rPr sz="1300" b="0">
                 <a:solidFill>
                   <a:srgbClr val="1B3A5F"/>
                 </a:solidFill>
                 <a:latin typeface="Arial"/>
               </a:rPr>
-              <a:t>TOTAL</a:t>
+              <a:t>0</a:t>
             </a:r>
           </a:p>
         </p:txBody>
@@ -4090,8 +4168,8 @@
         </p:nvSpPr>
         <p:spPr>
           <a:xfrm>
-            <a:off x="3840480" y="2651760"/>
-            <a:ext cx="1371600" cy="320040"/>
+            <a:off x="9784080" y="2057400"/>
+            <a:ext cx="1463040" cy="320040"/>
           </a:xfrm>
           <a:prstGeom prst="rect">
             <a:avLst/>
@@ -4106,13 +4184,13 @@
           <a:p>
             <a:pPr algn="l"/>
             <a:r>
-              <a:rPr sz="1400" b="1">
+              <a:rPr sz="1300" b="0">
                 <a:solidFill>
                   <a:srgbClr val="1B3A5F"/>
                 </a:solidFill>
                 <a:latin typeface="Arial"/>
               </a:rPr>
-              <a:t>161</a:t>
+              <a:t>2,715</a:t>
             </a:r>
           </a:p>
         </p:txBody>
@@ -4125,8 +4203,8 @@
         </p:nvSpPr>
         <p:spPr>
           <a:xfrm>
-            <a:off x="5486400" y="2651760"/>
-            <a:ext cx="1371600" cy="320040"/>
+            <a:off x="640080" y="2441448"/>
+            <a:ext cx="2926080" cy="320040"/>
           </a:xfrm>
           <a:prstGeom prst="rect">
             <a:avLst/>
@@ -4141,13 +4219,13 @@
           <a:p>
             <a:pPr algn="l"/>
             <a:r>
-              <a:rPr sz="1400" b="1">
+              <a:rPr sz="1300" b="0">
                 <a:solidFill>
                   <a:srgbClr val="1B3A5F"/>
                 </a:solidFill>
                 <a:latin typeface="Arial"/>
               </a:rPr>
-              <a:t>156</a:t>
+              <a:t>SMB</a:t>
             </a:r>
           </a:p>
         </p:txBody>
@@ -4160,7 +4238,7 @@
         </p:nvSpPr>
         <p:spPr>
           <a:xfrm>
-            <a:off x="7132320" y="2651760"/>
+            <a:off x="3657600" y="2441448"/>
             <a:ext cx="1371600" cy="320040"/>
           </a:xfrm>
           <a:prstGeom prst="rect">
@@ -4176,13 +4254,13 @@
           <a:p>
             <a:pPr algn="l"/>
             <a:r>
-              <a:rPr sz="1400" b="1">
+              <a:rPr sz="1300" b="1">
                 <a:solidFill>
                   <a:srgbClr val="1B3A5F"/>
                 </a:solidFill>
                 <a:latin typeface="Arial"/>
               </a:rPr>
-              <a:t>5</a:t>
+              <a:t>161</a:t>
             </a:r>
           </a:p>
         </p:txBody>
@@ -4195,8 +4273,8 @@
         </p:nvSpPr>
         <p:spPr>
           <a:xfrm>
-            <a:off x="8778240" y="2651760"/>
-            <a:ext cx="1645920" cy="320040"/>
+            <a:off x="5303520" y="2441448"/>
+            <a:ext cx="1280160" cy="320040"/>
           </a:xfrm>
           <a:prstGeom prst="rect">
             <a:avLst/>
@@ -4211,13 +4289,188 @@
           <a:p>
             <a:pPr algn="l"/>
             <a:r>
-              <a:rPr sz="1400" b="1">
+              <a:rPr sz="1300" b="0">
+                <a:solidFill>
+                  <a:srgbClr val="1B3A5F"/>
+                </a:solidFill>
+                <a:latin typeface="Arial"/>
+              </a:rPr>
+              <a:t>156</a:t>
+            </a:r>
+          </a:p>
+        </p:txBody>
+      </p:sp>
+      <p:sp>
+        <p:nvSpPr>
+          <p:cNvPr id="21" name="TextBox 20"/>
+          <p:cNvSpPr txBox="1"/>
+          <p:nvPr/>
+        </p:nvSpPr>
+        <p:spPr>
+          <a:xfrm>
+            <a:off x="6858000" y="2441448"/>
+            <a:ext cx="1280160" cy="320040"/>
+          </a:xfrm>
+          <a:prstGeom prst="rect">
+            <a:avLst/>
+          </a:prstGeom>
+          <a:noFill/>
+        </p:spPr>
+        <p:txBody>
+          <a:bodyPr wrap="square">
+            <a:spAutoFit/>
+          </a:bodyPr>
+          <a:lstStyle/>
+          <a:p>
+            <a:pPr algn="l"/>
+            <a:r>
+              <a:rPr sz="1300" b="0">
+                <a:solidFill>
+                  <a:srgbClr val="1B3A5F"/>
+                </a:solidFill>
+                <a:latin typeface="Arial"/>
+              </a:rPr>
+              <a:t>5</a:t>
+            </a:r>
+          </a:p>
+        </p:txBody>
+      </p:sp>
+      <p:sp>
+        <p:nvSpPr>
+          <p:cNvPr id="22" name="TextBox 21"/>
+          <p:cNvSpPr txBox="1"/>
+          <p:nvPr/>
+        </p:nvSpPr>
+        <p:spPr>
+          <a:xfrm>
+            <a:off x="8229600" y="2441448"/>
+            <a:ext cx="1280160" cy="320040"/>
+          </a:xfrm>
+          <a:prstGeom prst="rect">
+            <a:avLst/>
+          </a:prstGeom>
+          <a:noFill/>
+        </p:spPr>
+        <p:txBody>
+          <a:bodyPr wrap="square">
+            <a:spAutoFit/>
+          </a:bodyPr>
+          <a:lstStyle/>
+          <a:p>
+            <a:pPr algn="l"/>
+            <a:r>
+              <a:rPr sz="1300" b="0">
                 <a:solidFill>
                   <a:srgbClr val="1B3A5F"/>
                 </a:solidFill>
                 <a:latin typeface="Arial"/>
               </a:rPr>
               <a:t>0</a:t>
+            </a:r>
+          </a:p>
+        </p:txBody>
+      </p:sp>
+      <p:sp>
+        <p:nvSpPr>
+          <p:cNvPr id="23" name="TextBox 22"/>
+          <p:cNvSpPr txBox="1"/>
+          <p:nvPr/>
+        </p:nvSpPr>
+        <p:spPr>
+          <a:xfrm>
+            <a:off x="9784080" y="2441448"/>
+            <a:ext cx="1463040" cy="320040"/>
+          </a:xfrm>
+          <a:prstGeom prst="rect">
+            <a:avLst/>
+          </a:prstGeom>
+          <a:noFill/>
+        </p:spPr>
+        <p:txBody>
+          <a:bodyPr wrap="square">
+            <a:spAutoFit/>
+          </a:bodyPr>
+          <a:lstStyle/>
+          <a:p>
+            <a:pPr algn="l"/>
+            <a:r>
+              <a:rPr sz="1300" b="0">
+                <a:solidFill>
+                  <a:srgbClr val="1B3A5F"/>
+                </a:solidFill>
+                <a:latin typeface="Arial"/>
+              </a:rPr>
+              <a:t>0</a:t>
+            </a:r>
+          </a:p>
+        </p:txBody>
+      </p:sp>
+      <p:sp>
+        <p:nvSpPr>
+          <p:cNvPr id="24" name="TextBox 23"/>
+          <p:cNvSpPr txBox="1"/>
+          <p:nvPr/>
+        </p:nvSpPr>
+        <p:spPr>
+          <a:xfrm>
+            <a:off x="640080" y="2962656"/>
+            <a:ext cx="2926080" cy="320040"/>
+          </a:xfrm>
+          <a:prstGeom prst="rect">
+            <a:avLst/>
+          </a:prstGeom>
+          <a:noFill/>
+        </p:spPr>
+        <p:txBody>
+          <a:bodyPr wrap="square">
+            <a:spAutoFit/>
+          </a:bodyPr>
+          <a:lstStyle/>
+          <a:p>
+            <a:pPr algn="l"/>
+            <a:r>
+              <a:rPr sz="1300" b="1">
+                <a:solidFill>
+                  <a:srgbClr val="1B3A5F"/>
+                </a:solidFill>
+                <a:latin typeface="Arial"/>
+              </a:rPr>
+              <a:t>TOTAL</a:t>
+            </a:r>
+          </a:p>
+        </p:txBody>
+      </p:sp>
+      <p:sp>
+        <p:nvSpPr>
+          <p:cNvPr id="25" name="TextBox 24"/>
+          <p:cNvSpPr txBox="1"/>
+          <p:nvPr/>
+        </p:nvSpPr>
+        <p:spPr>
+          <a:xfrm>
+            <a:off x="3657600" y="2962656"/>
+            <a:ext cx="1371600" cy="320040"/>
+          </a:xfrm>
+          <a:prstGeom prst="rect">
+            <a:avLst/>
+          </a:prstGeom>
+          <a:noFill/>
+        </p:spPr>
+        <p:txBody>
+          <a:bodyPr wrap="square">
+            <a:spAutoFit/>
+          </a:bodyPr>
+          <a:lstStyle/>
+          <a:p>
+            <a:pPr algn="l"/>
+            <a:r>
+              <a:rPr sz="1300" b="1">
+                <a:solidFill>
+                  <a:srgbClr val="1B3A5F"/>
+                </a:solidFill>
+                <a:latin typeface="Arial"/>
+              </a:rPr>
+              <a:t>2,876</a:t>
             </a:r>
           </a:p>
         </p:txBody>

</xml_diff>

<commit_message>
Add Segment column per account and chart by segment
Enrich every created-after-July-13 account with Segment from the Room
Accounts Overview, export the consolidated CSV, and rebuild the progress
chart from the segment breakdown.

Co-authored-by: maiagordon-commits <maiagordon-commits@users.noreply.github.com>
</commit_message>
<xml_diff>
--- a/Room_Migration_Progress.pptx
+++ b/Room_Migration_Progress.pptx
@@ -6,7 +6,6 @@
   </p:sldMasterIdLst>
   <p:sldIdLst>
     <p:sldId id="256" r:id="rId7"/>
-    <p:sldId id="257" r:id="rId8"/>
   </p:sldIdLst>
   <p:sldSz cx="12191695" cy="6858000" type="screen4x3"/>
   <p:notesSz cx="6858000" cy="9144000"/>
@@ -3141,7 +3140,7 @@
         <p:spPr>
           <a:xfrm>
             <a:off x="502920" y="256032"/>
-            <a:ext cx="5486400" cy="502920"/>
+            <a:ext cx="6400800" cy="457200"/>
           </a:xfrm>
           <a:prstGeom prst="rect">
             <a:avLst/>
@@ -3156,7 +3155,7 @@
           <a:p>
             <a:pPr algn="l"/>
             <a:r>
-              <a:rPr sz="3000" b="1">
+              <a:rPr sz="2800" b="1">
                 <a:solidFill>
                   <a:srgbClr val="1B3A5F"/>
                 </a:solidFill>
@@ -3175,7 +3174,7 @@
         </p:nvSpPr>
         <p:spPr>
           <a:xfrm>
-            <a:off x="502920" y="822960"/>
+            <a:off x="502920" y="777240"/>
             <a:ext cx="2560320" cy="347472"/>
           </a:xfrm>
           <a:prstGeom prst="roundRect">
@@ -3229,8 +3228,8 @@
         </p:nvSpPr>
         <p:spPr>
           <a:xfrm>
-            <a:off x="4114800" y="274320"/>
-            <a:ext cx="3840480" cy="914400"/>
+            <a:off x="4206240" y="256032"/>
+            <a:ext cx="3657600" cy="914400"/>
           </a:xfrm>
           <a:prstGeom prst="roundRect">
             <a:avLst>
@@ -3264,7 +3263,7 @@
           <a:p>
             <a:pPr algn="ctr"/>
             <a:r>
-              <a:rPr sz="1100" b="0">
+              <a:rPr sz="1200" b="0">
                 <a:solidFill>
                   <a:srgbClr val="1B3A5F"/>
                 </a:solidFill>
@@ -3276,7 +3275,7 @@
           <a:p>
             <a:pPr algn="ctr"/>
             <a:r>
-              <a:rPr sz="2600" b="1">
+              <a:rPr sz="2800" b="1">
                 <a:solidFill>
                   <a:srgbClr val="1B3A5F"/>
                 </a:solidFill>
@@ -3330,25 +3329,25 @@
           <a:p>
             <a:pPr algn="ctr"/>
             <a:r>
-              <a:rPr sz="1100" b="0">
+              <a:rPr sz="1200" b="0">
                 <a:solidFill>
                   <a:srgbClr val="1B3A5F"/>
                 </a:solidFill>
                 <a:latin typeface="Arial"/>
               </a:rPr>
-              <a:t>Lite</a:t>
+              <a:t>SMB</a:t>
             </a:r>
           </a:p>
           <a:p>
             <a:pPr algn="ctr"/>
             <a:r>
-              <a:rPr sz="2600" b="1">
+              <a:rPr sz="2400" b="1">
                 <a:solidFill>
                   <a:srgbClr val="1B3A5F"/>
                 </a:solidFill>
                 <a:latin typeface="Arial"/>
               </a:rPr>
-              <a:t>156</a:t>
+              <a:t>161</a:t>
             </a:r>
           </a:p>
         </p:txBody>
@@ -3396,37 +3395,25 @@
           <a:p>
             <a:pPr algn="ctr"/>
             <a:r>
-              <a:rPr sz="1100" b="0">
+              <a:rPr sz="1200" b="0">
                 <a:solidFill>
                   <a:srgbClr val="1B3A5F"/>
                 </a:solidFill>
                 <a:latin typeface="Arial"/>
               </a:rPr>
-              <a:t>Pro</a:t>
+              <a:t>Mid-Market</a:t>
             </a:r>
           </a:p>
           <a:p>
             <a:pPr algn="ctr"/>
             <a:r>
-              <a:rPr sz="2600" b="1">
+              <a:rPr sz="2400" b="1">
                 <a:solidFill>
                   <a:srgbClr val="1B3A5F"/>
                 </a:solidFill>
                 <a:latin typeface="Arial"/>
               </a:rPr>
-              <a:t>5</a:t>
-            </a:r>
-          </a:p>
-          <a:p>
-            <a:pPr algn="ctr"/>
-            <a:r>
-              <a:rPr sz="900" b="0">
-                <a:solidFill>
-                  <a:srgbClr val="6B7C93"/>
-                </a:solidFill>
-                <a:latin typeface="Arial"/>
-              </a:rPr>
-              <a:t>Out of them 0 Mid Market</a:t>
+              <a:t>0</a:t>
             </a:r>
           </a:p>
         </p:txBody>
@@ -3474,19 +3461,19 @@
           <a:p>
             <a:pPr algn="ctr"/>
             <a:r>
-              <a:rPr sz="1100" b="0">
+              <a:rPr sz="1200" b="0">
                 <a:solidFill>
                   <a:srgbClr val="1B3A5F"/>
                 </a:solidFill>
                 <a:latin typeface="Arial"/>
               </a:rPr>
-              <a:t>Enterprise</a:t>
+              <a:t>SME</a:t>
             </a:r>
           </a:p>
           <a:p>
             <a:pPr algn="ctr"/>
             <a:r>
-              <a:rPr sz="2600" b="1">
+              <a:rPr sz="2400" b="1">
                 <a:solidFill>
                   <a:srgbClr val="1B3A5F"/>
                 </a:solidFill>
@@ -3540,19 +3527,19 @@
           <a:p>
             <a:pPr algn="ctr"/>
             <a:r>
-              <a:rPr sz="1100" b="0">
+              <a:rPr sz="1200" b="0">
                 <a:solidFill>
                   <a:srgbClr val="1B3A5F"/>
                 </a:solidFill>
                 <a:latin typeface="Arial"/>
               </a:rPr>
-              <a:t>Not in Room Overview</a:t>
+              <a:t>Unknown</a:t>
             </a:r>
           </a:p>
           <a:p>
             <a:pPr algn="ctr"/>
             <a:r>
-              <a:rPr sz="2200" b="1">
+              <a:rPr sz="2400" b="1">
                 <a:solidFill>
                   <a:srgbClr val="1B3A5F"/>
                 </a:solidFill>
@@ -3570,7 +3557,7 @@
                 </a:solidFill>
                 <a:latin typeface="Arial"/>
               </a:rPr>
-              <a:t>161 matched</a:t>
+              <a:t>161 from Room CSV</a:t>
             </a:r>
           </a:p>
         </p:txBody>
@@ -3599,882 +3586,6 @@
           </a:prstGeom>
         </p:spPr>
       </p:pic>
-    </p:spTree>
-  </p:cSld>
-  <p:clrMapOvr>
-    <a:masterClrMapping/>
-  </p:clrMapOvr>
-</p:sld>
-</file>
-
-<file path=ppt/slides/slide2.xml><?xml version="1.0" encoding="utf-8"?>
-<p:sld xmlns:a="http://schemas.openxmlformats.org/drawingml/2006/main" xmlns:p="http://schemas.openxmlformats.org/presentationml/2006/main" xmlns:r="http://schemas.openxmlformats.org/officeDocument/2006/relationships">
-  <p:cSld>
-    <p:spTree>
-      <p:nvGrpSpPr>
-        <p:cNvPr id="1" name=""/>
-        <p:cNvGrpSpPr/>
-        <p:nvPr/>
-      </p:nvGrpSpPr>
-      <p:grpSpPr/>
-      <p:sp>
-        <p:nvSpPr>
-          <p:cNvPr id="2" name="Rectangle 1"/>
-          <p:cNvSpPr/>
-          <p:nvPr/>
-        </p:nvSpPr>
-        <p:spPr>
-          <a:xfrm>
-            <a:off x="0" y="0"/>
-            <a:ext cx="12191695" cy="6858000"/>
-          </a:xfrm>
-          <a:prstGeom prst="rect">
-            <a:avLst/>
-          </a:prstGeom>
-          <a:solidFill>
-            <a:srgbClr val="F5F1E9"/>
-          </a:solidFill>
-          <a:ln>
-            <a:noFill/>
-          </a:ln>
-        </p:spPr>
-        <p:style>
-          <a:lnRef idx="1">
-            <a:schemeClr val="accent1"/>
-          </a:lnRef>
-          <a:fillRef idx="3">
-            <a:schemeClr val="accent1"/>
-          </a:fillRef>
-          <a:effectRef idx="2">
-            <a:schemeClr val="accent1"/>
-          </a:effectRef>
-          <a:fontRef idx="minor">
-            <a:schemeClr val="lt1"/>
-          </a:fontRef>
-        </p:style>
-        <p:txBody>
-          <a:bodyPr rtlCol="0" anchor="ctr"/>
-          <a:lstStyle/>
-          <a:p>
-            <a:pPr algn="ctr"/>
-          </a:p>
-        </p:txBody>
-      </p:sp>
-      <p:sp>
-        <p:nvSpPr>
-          <p:cNvPr id="3" name="TextBox 2"/>
-          <p:cNvSpPr txBox="1"/>
-          <p:nvPr/>
-        </p:nvSpPr>
-        <p:spPr>
-          <a:xfrm>
-            <a:off x="502920" y="320040"/>
-            <a:ext cx="10972800" cy="457200"/>
-          </a:xfrm>
-          <a:prstGeom prst="rect">
-            <a:avLst/>
-          </a:prstGeom>
-          <a:noFill/>
-        </p:spPr>
-        <p:txBody>
-          <a:bodyPr wrap="square">
-            <a:spAutoFit/>
-          </a:bodyPr>
-          <a:lstStyle/>
-          <a:p>
-            <a:pPr algn="l"/>
-            <a:r>
-              <a:rPr sz="2600" b="1">
-                <a:solidFill>
-                  <a:srgbClr val="1B3A5F"/>
-                </a:solidFill>
-                <a:latin typeface="Arial"/>
-              </a:rPr>
-              <a:t>Accounts Created After July 13 — Segment Breakdown</a:t>
-            </a:r>
-          </a:p>
-        </p:txBody>
-      </p:sp>
-      <p:sp>
-        <p:nvSpPr>
-          <p:cNvPr id="4" name="TextBox 3"/>
-          <p:cNvSpPr txBox="1"/>
-          <p:nvPr/>
-        </p:nvSpPr>
-        <p:spPr>
-          <a:xfrm>
-            <a:off x="502920" y="868680"/>
-            <a:ext cx="10972800" cy="411480"/>
-          </a:xfrm>
-          <a:prstGeom prst="rect">
-            <a:avLst/>
-          </a:prstGeom>
-          <a:noFill/>
-        </p:spPr>
-        <p:txBody>
-          <a:bodyPr wrap="square">
-            <a:spAutoFit/>
-          </a:bodyPr>
-          <a:lstStyle/>
-          <a:p>
-            <a:pPr algn="l"/>
-            <a:r>
-              <a:rPr sz="1300" b="0">
-                <a:solidFill>
-                  <a:srgbClr val="6B7C93"/>
-                </a:solidFill>
-                <a:latin typeface="Arial"/>
-              </a:rPr>
-              <a:t>All created accounts: 2,876  ·  Found in Room Overview (Package/Segment available): 161  ·  Not in Room Overview: 2,715</a:t>
-            </a:r>
-          </a:p>
-        </p:txBody>
-      </p:sp>
-      <p:sp>
-        <p:nvSpPr>
-          <p:cNvPr id="5" name="Rounded Rectangle 4"/>
-          <p:cNvSpPr/>
-          <p:nvPr/>
-        </p:nvSpPr>
-        <p:spPr>
-          <a:xfrm>
-            <a:off x="502920" y="1463040"/>
-            <a:ext cx="11155680" cy="457200"/>
-          </a:xfrm>
-          <a:prstGeom prst="roundRect">
-            <a:avLst>
-              <a:gd name="adj" fmla="val 12000"/>
-            </a:avLst>
-          </a:prstGeom>
-          <a:solidFill>
-            <a:srgbClr val="D9EAF7"/>
-          </a:solidFill>
-          <a:ln>
-            <a:noFill/>
-          </a:ln>
-        </p:spPr>
-        <p:style>
-          <a:lnRef idx="1">
-            <a:schemeClr val="accent1"/>
-          </a:lnRef>
-          <a:fillRef idx="3">
-            <a:schemeClr val="accent1"/>
-          </a:fillRef>
-          <a:effectRef idx="2">
-            <a:schemeClr val="accent1"/>
-          </a:effectRef>
-          <a:fontRef idx="minor">
-            <a:schemeClr val="lt1"/>
-          </a:fontRef>
-        </p:style>
-        <p:txBody>
-          <a:bodyPr rtlCol="0" anchor="ctr"/>
-          <a:lstStyle/>
-          <a:p>
-            <a:pPr algn="ctr"/>
-          </a:p>
-        </p:txBody>
-      </p:sp>
-      <p:sp>
-        <p:nvSpPr>
-          <p:cNvPr id="6" name="TextBox 5"/>
-          <p:cNvSpPr txBox="1"/>
-          <p:nvPr/>
-        </p:nvSpPr>
-        <p:spPr>
-          <a:xfrm>
-            <a:off x="640080" y="1536192"/>
-            <a:ext cx="1645920" cy="320040"/>
-          </a:xfrm>
-          <a:prstGeom prst="rect">
-            <a:avLst/>
-          </a:prstGeom>
-          <a:noFill/>
-        </p:spPr>
-        <p:txBody>
-          <a:bodyPr wrap="square">
-            <a:spAutoFit/>
-          </a:bodyPr>
-          <a:lstStyle/>
-          <a:p>
-            <a:pPr algn="l"/>
-            <a:r>
-              <a:rPr sz="1300" b="1">
-                <a:solidFill>
-                  <a:srgbClr val="1B3A5F"/>
-                </a:solidFill>
-                <a:latin typeface="Arial"/>
-              </a:rPr>
-              <a:t>Segment</a:t>
-            </a:r>
-          </a:p>
-        </p:txBody>
-      </p:sp>
-      <p:sp>
-        <p:nvSpPr>
-          <p:cNvPr id="7" name="TextBox 6"/>
-          <p:cNvSpPr txBox="1"/>
-          <p:nvPr/>
-        </p:nvSpPr>
-        <p:spPr>
-          <a:xfrm>
-            <a:off x="3657600" y="1536192"/>
-            <a:ext cx="1645920" cy="320040"/>
-          </a:xfrm>
-          <a:prstGeom prst="rect">
-            <a:avLst/>
-          </a:prstGeom>
-          <a:noFill/>
-        </p:spPr>
-        <p:txBody>
-          <a:bodyPr wrap="square">
-            <a:spAutoFit/>
-          </a:bodyPr>
-          <a:lstStyle/>
-          <a:p>
-            <a:pPr algn="l"/>
-            <a:r>
-              <a:rPr sz="1300" b="1">
-                <a:solidFill>
-                  <a:srgbClr val="1B3A5F"/>
-                </a:solidFill>
-                <a:latin typeface="Arial"/>
-              </a:rPr>
-              <a:t>Total</a:t>
-            </a:r>
-          </a:p>
-        </p:txBody>
-      </p:sp>
-      <p:sp>
-        <p:nvSpPr>
-          <p:cNvPr id="8" name="TextBox 7"/>
-          <p:cNvSpPr txBox="1"/>
-          <p:nvPr/>
-        </p:nvSpPr>
-        <p:spPr>
-          <a:xfrm>
-            <a:off x="5303520" y="1536192"/>
-            <a:ext cx="1645920" cy="320040"/>
-          </a:xfrm>
-          <a:prstGeom prst="rect">
-            <a:avLst/>
-          </a:prstGeom>
-          <a:noFill/>
-        </p:spPr>
-        <p:txBody>
-          <a:bodyPr wrap="square">
-            <a:spAutoFit/>
-          </a:bodyPr>
-          <a:lstStyle/>
-          <a:p>
-            <a:pPr algn="l"/>
-            <a:r>
-              <a:rPr sz="1300" b="1">
-                <a:solidFill>
-                  <a:srgbClr val="1B3A5F"/>
-                </a:solidFill>
-                <a:latin typeface="Arial"/>
-              </a:rPr>
-              <a:t>Lite</a:t>
-            </a:r>
-          </a:p>
-        </p:txBody>
-      </p:sp>
-      <p:sp>
-        <p:nvSpPr>
-          <p:cNvPr id="9" name="TextBox 8"/>
-          <p:cNvSpPr txBox="1"/>
-          <p:nvPr/>
-        </p:nvSpPr>
-        <p:spPr>
-          <a:xfrm>
-            <a:off x="6858000" y="1536192"/>
-            <a:ext cx="1645920" cy="320040"/>
-          </a:xfrm>
-          <a:prstGeom prst="rect">
-            <a:avLst/>
-          </a:prstGeom>
-          <a:noFill/>
-        </p:spPr>
-        <p:txBody>
-          <a:bodyPr wrap="square">
-            <a:spAutoFit/>
-          </a:bodyPr>
-          <a:lstStyle/>
-          <a:p>
-            <a:pPr algn="l"/>
-            <a:r>
-              <a:rPr sz="1300" b="1">
-                <a:solidFill>
-                  <a:srgbClr val="1B3A5F"/>
-                </a:solidFill>
-                <a:latin typeface="Arial"/>
-              </a:rPr>
-              <a:t>Pro</a:t>
-            </a:r>
-          </a:p>
-        </p:txBody>
-      </p:sp>
-      <p:sp>
-        <p:nvSpPr>
-          <p:cNvPr id="10" name="TextBox 9"/>
-          <p:cNvSpPr txBox="1"/>
-          <p:nvPr/>
-        </p:nvSpPr>
-        <p:spPr>
-          <a:xfrm>
-            <a:off x="8229600" y="1536192"/>
-            <a:ext cx="1645920" cy="320040"/>
-          </a:xfrm>
-          <a:prstGeom prst="rect">
-            <a:avLst/>
-          </a:prstGeom>
-          <a:noFill/>
-        </p:spPr>
-        <p:txBody>
-          <a:bodyPr wrap="square">
-            <a:spAutoFit/>
-          </a:bodyPr>
-          <a:lstStyle/>
-          <a:p>
-            <a:pPr algn="l"/>
-            <a:r>
-              <a:rPr sz="1300" b="1">
-                <a:solidFill>
-                  <a:srgbClr val="1B3A5F"/>
-                </a:solidFill>
-                <a:latin typeface="Arial"/>
-              </a:rPr>
-              <a:t>Enterprise</a:t>
-            </a:r>
-          </a:p>
-        </p:txBody>
-      </p:sp>
-      <p:sp>
-        <p:nvSpPr>
-          <p:cNvPr id="11" name="TextBox 10"/>
-          <p:cNvSpPr txBox="1"/>
-          <p:nvPr/>
-        </p:nvSpPr>
-        <p:spPr>
-          <a:xfrm>
-            <a:off x="9784080" y="1536192"/>
-            <a:ext cx="1645920" cy="320040"/>
-          </a:xfrm>
-          <a:prstGeom prst="rect">
-            <a:avLst/>
-          </a:prstGeom>
-          <a:noFill/>
-        </p:spPr>
-        <p:txBody>
-          <a:bodyPr wrap="square">
-            <a:spAutoFit/>
-          </a:bodyPr>
-          <a:lstStyle/>
-          <a:p>
-            <a:pPr algn="l"/>
-            <a:r>
-              <a:rPr sz="1300" b="1">
-                <a:solidFill>
-                  <a:srgbClr val="1B3A5F"/>
-                </a:solidFill>
-                <a:latin typeface="Arial"/>
-              </a:rPr>
-              <a:t>Not in Room</a:t>
-            </a:r>
-          </a:p>
-        </p:txBody>
-      </p:sp>
-      <p:sp>
-        <p:nvSpPr>
-          <p:cNvPr id="12" name="TextBox 11"/>
-          <p:cNvSpPr txBox="1"/>
-          <p:nvPr/>
-        </p:nvSpPr>
-        <p:spPr>
-          <a:xfrm>
-            <a:off x="640080" y="2057400"/>
-            <a:ext cx="2926080" cy="320040"/>
-          </a:xfrm>
-          <a:prstGeom prst="rect">
-            <a:avLst/>
-          </a:prstGeom>
-          <a:noFill/>
-        </p:spPr>
-        <p:txBody>
-          <a:bodyPr wrap="square">
-            <a:spAutoFit/>
-          </a:bodyPr>
-          <a:lstStyle/>
-          <a:p>
-            <a:pPr algn="l"/>
-            <a:r>
-              <a:rPr sz="1300" b="0">
-                <a:solidFill>
-                  <a:srgbClr val="1B3A5F"/>
-                </a:solidFill>
-                <a:latin typeface="Arial"/>
-              </a:rPr>
-              <a:t>Not in Room Overview</a:t>
-            </a:r>
-          </a:p>
-        </p:txBody>
-      </p:sp>
-      <p:sp>
-        <p:nvSpPr>
-          <p:cNvPr id="13" name="TextBox 12"/>
-          <p:cNvSpPr txBox="1"/>
-          <p:nvPr/>
-        </p:nvSpPr>
-        <p:spPr>
-          <a:xfrm>
-            <a:off x="3657600" y="2057400"/>
-            <a:ext cx="1371600" cy="320040"/>
-          </a:xfrm>
-          <a:prstGeom prst="rect">
-            <a:avLst/>
-          </a:prstGeom>
-          <a:noFill/>
-        </p:spPr>
-        <p:txBody>
-          <a:bodyPr wrap="square">
-            <a:spAutoFit/>
-          </a:bodyPr>
-          <a:lstStyle/>
-          <a:p>
-            <a:pPr algn="l"/>
-            <a:r>
-              <a:rPr sz="1300" b="1">
-                <a:solidFill>
-                  <a:srgbClr val="1B3A5F"/>
-                </a:solidFill>
-                <a:latin typeface="Arial"/>
-              </a:rPr>
-              <a:t>2,715</a:t>
-            </a:r>
-          </a:p>
-        </p:txBody>
-      </p:sp>
-      <p:sp>
-        <p:nvSpPr>
-          <p:cNvPr id="14" name="TextBox 13"/>
-          <p:cNvSpPr txBox="1"/>
-          <p:nvPr/>
-        </p:nvSpPr>
-        <p:spPr>
-          <a:xfrm>
-            <a:off x="5303520" y="2057400"/>
-            <a:ext cx="1280160" cy="320040"/>
-          </a:xfrm>
-          <a:prstGeom prst="rect">
-            <a:avLst/>
-          </a:prstGeom>
-          <a:noFill/>
-        </p:spPr>
-        <p:txBody>
-          <a:bodyPr wrap="square">
-            <a:spAutoFit/>
-          </a:bodyPr>
-          <a:lstStyle/>
-          <a:p>
-            <a:pPr algn="l"/>
-            <a:r>
-              <a:rPr sz="1300" b="0">
-                <a:solidFill>
-                  <a:srgbClr val="1B3A5F"/>
-                </a:solidFill>
-                <a:latin typeface="Arial"/>
-              </a:rPr>
-              <a:t>0</a:t>
-            </a:r>
-          </a:p>
-        </p:txBody>
-      </p:sp>
-      <p:sp>
-        <p:nvSpPr>
-          <p:cNvPr id="15" name="TextBox 14"/>
-          <p:cNvSpPr txBox="1"/>
-          <p:nvPr/>
-        </p:nvSpPr>
-        <p:spPr>
-          <a:xfrm>
-            <a:off x="6858000" y="2057400"/>
-            <a:ext cx="1280160" cy="320040"/>
-          </a:xfrm>
-          <a:prstGeom prst="rect">
-            <a:avLst/>
-          </a:prstGeom>
-          <a:noFill/>
-        </p:spPr>
-        <p:txBody>
-          <a:bodyPr wrap="square">
-            <a:spAutoFit/>
-          </a:bodyPr>
-          <a:lstStyle/>
-          <a:p>
-            <a:pPr algn="l"/>
-            <a:r>
-              <a:rPr sz="1300" b="0">
-                <a:solidFill>
-                  <a:srgbClr val="1B3A5F"/>
-                </a:solidFill>
-                <a:latin typeface="Arial"/>
-              </a:rPr>
-              <a:t>0</a:t>
-            </a:r>
-          </a:p>
-        </p:txBody>
-      </p:sp>
-      <p:sp>
-        <p:nvSpPr>
-          <p:cNvPr id="16" name="TextBox 15"/>
-          <p:cNvSpPr txBox="1"/>
-          <p:nvPr/>
-        </p:nvSpPr>
-        <p:spPr>
-          <a:xfrm>
-            <a:off x="8229600" y="2057400"/>
-            <a:ext cx="1280160" cy="320040"/>
-          </a:xfrm>
-          <a:prstGeom prst="rect">
-            <a:avLst/>
-          </a:prstGeom>
-          <a:noFill/>
-        </p:spPr>
-        <p:txBody>
-          <a:bodyPr wrap="square">
-            <a:spAutoFit/>
-          </a:bodyPr>
-          <a:lstStyle/>
-          <a:p>
-            <a:pPr algn="l"/>
-            <a:r>
-              <a:rPr sz="1300" b="0">
-                <a:solidFill>
-                  <a:srgbClr val="1B3A5F"/>
-                </a:solidFill>
-                <a:latin typeface="Arial"/>
-              </a:rPr>
-              <a:t>0</a:t>
-            </a:r>
-          </a:p>
-        </p:txBody>
-      </p:sp>
-      <p:sp>
-        <p:nvSpPr>
-          <p:cNvPr id="17" name="TextBox 16"/>
-          <p:cNvSpPr txBox="1"/>
-          <p:nvPr/>
-        </p:nvSpPr>
-        <p:spPr>
-          <a:xfrm>
-            <a:off x="9784080" y="2057400"/>
-            <a:ext cx="1463040" cy="320040"/>
-          </a:xfrm>
-          <a:prstGeom prst="rect">
-            <a:avLst/>
-          </a:prstGeom>
-          <a:noFill/>
-        </p:spPr>
-        <p:txBody>
-          <a:bodyPr wrap="square">
-            <a:spAutoFit/>
-          </a:bodyPr>
-          <a:lstStyle/>
-          <a:p>
-            <a:pPr algn="l"/>
-            <a:r>
-              <a:rPr sz="1300" b="0">
-                <a:solidFill>
-                  <a:srgbClr val="1B3A5F"/>
-                </a:solidFill>
-                <a:latin typeface="Arial"/>
-              </a:rPr>
-              <a:t>2,715</a:t>
-            </a:r>
-          </a:p>
-        </p:txBody>
-      </p:sp>
-      <p:sp>
-        <p:nvSpPr>
-          <p:cNvPr id="18" name="TextBox 17"/>
-          <p:cNvSpPr txBox="1"/>
-          <p:nvPr/>
-        </p:nvSpPr>
-        <p:spPr>
-          <a:xfrm>
-            <a:off x="640080" y="2441448"/>
-            <a:ext cx="2926080" cy="320040"/>
-          </a:xfrm>
-          <a:prstGeom prst="rect">
-            <a:avLst/>
-          </a:prstGeom>
-          <a:noFill/>
-        </p:spPr>
-        <p:txBody>
-          <a:bodyPr wrap="square">
-            <a:spAutoFit/>
-          </a:bodyPr>
-          <a:lstStyle/>
-          <a:p>
-            <a:pPr algn="l"/>
-            <a:r>
-              <a:rPr sz="1300" b="0">
-                <a:solidFill>
-                  <a:srgbClr val="1B3A5F"/>
-                </a:solidFill>
-                <a:latin typeface="Arial"/>
-              </a:rPr>
-              <a:t>SMB</a:t>
-            </a:r>
-          </a:p>
-        </p:txBody>
-      </p:sp>
-      <p:sp>
-        <p:nvSpPr>
-          <p:cNvPr id="19" name="TextBox 18"/>
-          <p:cNvSpPr txBox="1"/>
-          <p:nvPr/>
-        </p:nvSpPr>
-        <p:spPr>
-          <a:xfrm>
-            <a:off x="3657600" y="2441448"/>
-            <a:ext cx="1371600" cy="320040"/>
-          </a:xfrm>
-          <a:prstGeom prst="rect">
-            <a:avLst/>
-          </a:prstGeom>
-          <a:noFill/>
-        </p:spPr>
-        <p:txBody>
-          <a:bodyPr wrap="square">
-            <a:spAutoFit/>
-          </a:bodyPr>
-          <a:lstStyle/>
-          <a:p>
-            <a:pPr algn="l"/>
-            <a:r>
-              <a:rPr sz="1300" b="1">
-                <a:solidFill>
-                  <a:srgbClr val="1B3A5F"/>
-                </a:solidFill>
-                <a:latin typeface="Arial"/>
-              </a:rPr>
-              <a:t>161</a:t>
-            </a:r>
-          </a:p>
-        </p:txBody>
-      </p:sp>
-      <p:sp>
-        <p:nvSpPr>
-          <p:cNvPr id="20" name="TextBox 19"/>
-          <p:cNvSpPr txBox="1"/>
-          <p:nvPr/>
-        </p:nvSpPr>
-        <p:spPr>
-          <a:xfrm>
-            <a:off x="5303520" y="2441448"/>
-            <a:ext cx="1280160" cy="320040"/>
-          </a:xfrm>
-          <a:prstGeom prst="rect">
-            <a:avLst/>
-          </a:prstGeom>
-          <a:noFill/>
-        </p:spPr>
-        <p:txBody>
-          <a:bodyPr wrap="square">
-            <a:spAutoFit/>
-          </a:bodyPr>
-          <a:lstStyle/>
-          <a:p>
-            <a:pPr algn="l"/>
-            <a:r>
-              <a:rPr sz="1300" b="0">
-                <a:solidFill>
-                  <a:srgbClr val="1B3A5F"/>
-                </a:solidFill>
-                <a:latin typeface="Arial"/>
-              </a:rPr>
-              <a:t>156</a:t>
-            </a:r>
-          </a:p>
-        </p:txBody>
-      </p:sp>
-      <p:sp>
-        <p:nvSpPr>
-          <p:cNvPr id="21" name="TextBox 20"/>
-          <p:cNvSpPr txBox="1"/>
-          <p:nvPr/>
-        </p:nvSpPr>
-        <p:spPr>
-          <a:xfrm>
-            <a:off x="6858000" y="2441448"/>
-            <a:ext cx="1280160" cy="320040"/>
-          </a:xfrm>
-          <a:prstGeom prst="rect">
-            <a:avLst/>
-          </a:prstGeom>
-          <a:noFill/>
-        </p:spPr>
-        <p:txBody>
-          <a:bodyPr wrap="square">
-            <a:spAutoFit/>
-          </a:bodyPr>
-          <a:lstStyle/>
-          <a:p>
-            <a:pPr algn="l"/>
-            <a:r>
-              <a:rPr sz="1300" b="0">
-                <a:solidFill>
-                  <a:srgbClr val="1B3A5F"/>
-                </a:solidFill>
-                <a:latin typeface="Arial"/>
-              </a:rPr>
-              <a:t>5</a:t>
-            </a:r>
-          </a:p>
-        </p:txBody>
-      </p:sp>
-      <p:sp>
-        <p:nvSpPr>
-          <p:cNvPr id="22" name="TextBox 21"/>
-          <p:cNvSpPr txBox="1"/>
-          <p:nvPr/>
-        </p:nvSpPr>
-        <p:spPr>
-          <a:xfrm>
-            <a:off x="8229600" y="2441448"/>
-            <a:ext cx="1280160" cy="320040"/>
-          </a:xfrm>
-          <a:prstGeom prst="rect">
-            <a:avLst/>
-          </a:prstGeom>
-          <a:noFill/>
-        </p:spPr>
-        <p:txBody>
-          <a:bodyPr wrap="square">
-            <a:spAutoFit/>
-          </a:bodyPr>
-          <a:lstStyle/>
-          <a:p>
-            <a:pPr algn="l"/>
-            <a:r>
-              <a:rPr sz="1300" b="0">
-                <a:solidFill>
-                  <a:srgbClr val="1B3A5F"/>
-                </a:solidFill>
-                <a:latin typeface="Arial"/>
-              </a:rPr>
-              <a:t>0</a:t>
-            </a:r>
-          </a:p>
-        </p:txBody>
-      </p:sp>
-      <p:sp>
-        <p:nvSpPr>
-          <p:cNvPr id="23" name="TextBox 22"/>
-          <p:cNvSpPr txBox="1"/>
-          <p:nvPr/>
-        </p:nvSpPr>
-        <p:spPr>
-          <a:xfrm>
-            <a:off x="9784080" y="2441448"/>
-            <a:ext cx="1463040" cy="320040"/>
-          </a:xfrm>
-          <a:prstGeom prst="rect">
-            <a:avLst/>
-          </a:prstGeom>
-          <a:noFill/>
-        </p:spPr>
-        <p:txBody>
-          <a:bodyPr wrap="square">
-            <a:spAutoFit/>
-          </a:bodyPr>
-          <a:lstStyle/>
-          <a:p>
-            <a:pPr algn="l"/>
-            <a:r>
-              <a:rPr sz="1300" b="0">
-                <a:solidFill>
-                  <a:srgbClr val="1B3A5F"/>
-                </a:solidFill>
-                <a:latin typeface="Arial"/>
-              </a:rPr>
-              <a:t>0</a:t>
-            </a:r>
-          </a:p>
-        </p:txBody>
-      </p:sp>
-      <p:sp>
-        <p:nvSpPr>
-          <p:cNvPr id="24" name="TextBox 23"/>
-          <p:cNvSpPr txBox="1"/>
-          <p:nvPr/>
-        </p:nvSpPr>
-        <p:spPr>
-          <a:xfrm>
-            <a:off x="640080" y="2962656"/>
-            <a:ext cx="2926080" cy="320040"/>
-          </a:xfrm>
-          <a:prstGeom prst="rect">
-            <a:avLst/>
-          </a:prstGeom>
-          <a:noFill/>
-        </p:spPr>
-        <p:txBody>
-          <a:bodyPr wrap="square">
-            <a:spAutoFit/>
-          </a:bodyPr>
-          <a:lstStyle/>
-          <a:p>
-            <a:pPr algn="l"/>
-            <a:r>
-              <a:rPr sz="1300" b="1">
-                <a:solidFill>
-                  <a:srgbClr val="1B3A5F"/>
-                </a:solidFill>
-                <a:latin typeface="Arial"/>
-              </a:rPr>
-              <a:t>TOTAL</a:t>
-            </a:r>
-          </a:p>
-        </p:txBody>
-      </p:sp>
-      <p:sp>
-        <p:nvSpPr>
-          <p:cNvPr id="25" name="TextBox 24"/>
-          <p:cNvSpPr txBox="1"/>
-          <p:nvPr/>
-        </p:nvSpPr>
-        <p:spPr>
-          <a:xfrm>
-            <a:off x="3657600" y="2962656"/>
-            <a:ext cx="1371600" cy="320040"/>
-          </a:xfrm>
-          <a:prstGeom prst="rect">
-            <a:avLst/>
-          </a:prstGeom>
-          <a:noFill/>
-        </p:spPr>
-        <p:txBody>
-          <a:bodyPr wrap="square">
-            <a:spAutoFit/>
-          </a:bodyPr>
-          <a:lstStyle/>
-          <a:p>
-            <a:pPr algn="l"/>
-            <a:r>
-              <a:rPr sz="1300" b="1">
-                <a:solidFill>
-                  <a:srgbClr val="1B3A5F"/>
-                </a:solidFill>
-                <a:latin typeface="Arial"/>
-              </a:rPr>
-              <a:t>2,876</a:t>
-            </a:r>
-          </a:p>
-        </p:txBody>
-      </p:sp>
     </p:spTree>
   </p:cSld>
   <p:clrMapOvr>

</xml_diff>

<commit_message>
Simplify chart to Total, SMB, and Lite
Keep Total Accounts Created unchanged, set SMB to the 161 Room-matched
accounts, and set Lite to Total minus SMB (2,715). Rebuild the progress
slide and cumulative weekly chart.

Co-authored-by: maiagordon-commits <maiagordon-commits@users.noreply.github.com>
</commit_message>
<xml_diff>
--- a/Room_Migration_Progress.pptx
+++ b/Room_Migration_Progress.pptx
@@ -3228,7 +3228,7 @@
         </p:nvSpPr>
         <p:spPr>
           <a:xfrm>
-            <a:off x="4206240" y="256032"/>
+            <a:off x="4206240" y="274320"/>
             <a:ext cx="3657600" cy="914400"/>
           </a:xfrm>
           <a:prstGeom prst="roundRect">
@@ -3263,7 +3263,7 @@
           <a:p>
             <a:pPr algn="ctr"/>
             <a:r>
-              <a:rPr sz="1200" b="0">
+              <a:rPr sz="1300" b="0">
                 <a:solidFill>
                   <a:srgbClr val="1B3A5F"/>
                 </a:solidFill>
@@ -3294,8 +3294,8 @@
         </p:nvSpPr>
         <p:spPr>
           <a:xfrm>
-            <a:off x="502920" y="1371600"/>
-            <a:ext cx="2651760" cy="960120"/>
+            <a:off x="2286000" y="1417320"/>
+            <a:ext cx="3291840" cy="960120"/>
           </a:xfrm>
           <a:prstGeom prst="roundRect">
             <a:avLst>
@@ -3329,7 +3329,7 @@
           <a:p>
             <a:pPr algn="ctr"/>
             <a:r>
-              <a:rPr sz="1200" b="0">
+              <a:rPr sz="1300" b="0">
                 <a:solidFill>
                   <a:srgbClr val="1B3A5F"/>
                 </a:solidFill>
@@ -3341,7 +3341,7 @@
           <a:p>
             <a:pPr algn="ctr"/>
             <a:r>
-              <a:rPr sz="2400" b="1">
+              <a:rPr sz="2800" b="1">
                 <a:solidFill>
                   <a:srgbClr val="1B3A5F"/>
                 </a:solidFill>
@@ -3360,8 +3360,8 @@
         </p:nvSpPr>
         <p:spPr>
           <a:xfrm>
-            <a:off x="3337560" y="1371600"/>
-            <a:ext cx="2651760" cy="960120"/>
+            <a:off x="6400800" y="1417320"/>
+            <a:ext cx="3291840" cy="960120"/>
           </a:xfrm>
           <a:prstGeom prst="roundRect">
             <a:avLst>
@@ -3395,151 +3395,19 @@
           <a:p>
             <a:pPr algn="ctr"/>
             <a:r>
-              <a:rPr sz="1200" b="0">
+              <a:rPr sz="1300" b="0">
                 <a:solidFill>
                   <a:srgbClr val="1B3A5F"/>
                 </a:solidFill>
                 <a:latin typeface="Arial"/>
               </a:rPr>
-              <a:t>Mid-Market</a:t>
+              <a:t>Lite</a:t>
             </a:r>
           </a:p>
           <a:p>
             <a:pPr algn="ctr"/>
             <a:r>
-              <a:rPr sz="2400" b="1">
-                <a:solidFill>
-                  <a:srgbClr val="1B3A5F"/>
-                </a:solidFill>
-                <a:latin typeface="Arial"/>
-              </a:rPr>
-              <a:t>0</a:t>
-            </a:r>
-          </a:p>
-        </p:txBody>
-      </p:sp>
-      <p:sp>
-        <p:nvSpPr>
-          <p:cNvPr id="8" name="Rounded Rectangle 7"/>
-          <p:cNvSpPr/>
-          <p:nvPr/>
-        </p:nvSpPr>
-        <p:spPr>
-          <a:xfrm>
-            <a:off x="6172200" y="1371600"/>
-            <a:ext cx="2651760" cy="960120"/>
-          </a:xfrm>
-          <a:prstGeom prst="roundRect">
-            <a:avLst>
-              <a:gd name="adj" fmla="val 12000"/>
-            </a:avLst>
-          </a:prstGeom>
-          <a:solidFill>
-            <a:srgbClr val="D9EAF7"/>
-          </a:solidFill>
-          <a:ln>
-            <a:noFill/>
-          </a:ln>
-        </p:spPr>
-        <p:style>
-          <a:lnRef idx="1">
-            <a:schemeClr val="accent1"/>
-          </a:lnRef>
-          <a:fillRef idx="3">
-            <a:schemeClr val="accent1"/>
-          </a:fillRef>
-          <a:effectRef idx="2">
-            <a:schemeClr val="accent1"/>
-          </a:effectRef>
-          <a:fontRef idx="minor">
-            <a:schemeClr val="lt1"/>
-          </a:fontRef>
-        </p:style>
-        <p:txBody>
-          <a:bodyPr rtlCol="0" anchor="ctr" wrap="square"/>
-          <a:lstStyle/>
-          <a:p>
-            <a:pPr algn="ctr"/>
-            <a:r>
-              <a:rPr sz="1200" b="0">
-                <a:solidFill>
-                  <a:srgbClr val="1B3A5F"/>
-                </a:solidFill>
-                <a:latin typeface="Arial"/>
-              </a:rPr>
-              <a:t>SME</a:t>
-            </a:r>
-          </a:p>
-          <a:p>
-            <a:pPr algn="ctr"/>
-            <a:r>
-              <a:rPr sz="2400" b="1">
-                <a:solidFill>
-                  <a:srgbClr val="1B3A5F"/>
-                </a:solidFill>
-                <a:latin typeface="Arial"/>
-              </a:rPr>
-              <a:t>0</a:t>
-            </a:r>
-          </a:p>
-        </p:txBody>
-      </p:sp>
-      <p:sp>
-        <p:nvSpPr>
-          <p:cNvPr id="9" name="Rounded Rectangle 8"/>
-          <p:cNvSpPr/>
-          <p:nvPr/>
-        </p:nvSpPr>
-        <p:spPr>
-          <a:xfrm>
-            <a:off x="9006840" y="1371600"/>
-            <a:ext cx="2651760" cy="960120"/>
-          </a:xfrm>
-          <a:prstGeom prst="roundRect">
-            <a:avLst>
-              <a:gd name="adj" fmla="val 12000"/>
-            </a:avLst>
-          </a:prstGeom>
-          <a:solidFill>
-            <a:srgbClr val="D9EAF7"/>
-          </a:solidFill>
-          <a:ln>
-            <a:noFill/>
-          </a:ln>
-        </p:spPr>
-        <p:style>
-          <a:lnRef idx="1">
-            <a:schemeClr val="accent1"/>
-          </a:lnRef>
-          <a:fillRef idx="3">
-            <a:schemeClr val="accent1"/>
-          </a:fillRef>
-          <a:effectRef idx="2">
-            <a:schemeClr val="accent1"/>
-          </a:effectRef>
-          <a:fontRef idx="minor">
-            <a:schemeClr val="lt1"/>
-          </a:fontRef>
-        </p:style>
-        <p:txBody>
-          <a:bodyPr rtlCol="0" anchor="ctr" wrap="square"/>
-          <a:lstStyle/>
-          <a:p>
-            <a:pPr algn="ctr"/>
-            <a:r>
-              <a:rPr sz="1200" b="0">
-                <a:solidFill>
-                  <a:srgbClr val="1B3A5F"/>
-                </a:solidFill>
-                <a:latin typeface="Arial"/>
-              </a:rPr>
-              <a:t>Unknown</a:t>
-            </a:r>
-          </a:p>
-          <a:p>
-            <a:pPr algn="ctr"/>
-            <a:r>
-              <a:rPr sz="2400" b="1">
+              <a:rPr sz="2800" b="1">
                 <a:solidFill>
                   <a:srgbClr val="1B3A5F"/>
                 </a:solidFill>
@@ -3548,23 +3416,11 @@
               <a:t>2,715</a:t>
             </a:r>
           </a:p>
-          <a:p>
-            <a:pPr algn="ctr"/>
-            <a:r>
-              <a:rPr sz="900" b="0">
-                <a:solidFill>
-                  <a:srgbClr val="6B7C93"/>
-                </a:solidFill>
-                <a:latin typeface="Arial"/>
-              </a:rPr>
-              <a:t>161 from Room CSV</a:t>
-            </a:r>
-          </a:p>
         </p:txBody>
       </p:sp>
       <p:pic>
         <p:nvPicPr>
-          <p:cNvPr id="10" name="Picture 9" descr="room-migration-chart.png"/>
+          <p:cNvPr id="8" name="Picture 7" descr="room-migration-chart.png"/>
           <p:cNvPicPr>
             <a:picLocks noChangeAspect="1"/>
           </p:cNvPicPr>
@@ -3578,7 +3434,7 @@
         </p:blipFill>
         <p:spPr>
           <a:xfrm>
-            <a:off x="502920" y="2606040"/>
+            <a:off x="502920" y="2651760"/>
             <a:ext cx="11155680" cy="3657600"/>
           </a:xfrm>
           <a:prstGeom prst="rect">

</xml_diff>

<commit_message>
Refresh Room Migration chart with week of Aug 3 data
Merge 1,519 accounts created after July 27 into the cumulative set,
update Room Overview matching for Pro/Lite, and regenerate both deck
variants through the week of July 27 (clean) / August 3 (full).

Co-authored-by: maiagordon-commits <maiagordon-commits@users.noreply.github.com>
</commit_message>
<xml_diff>
--- a/Room_Migration_Progress.pptx
+++ b/Room_Migration_Progress.pptx
@@ -3215,7 +3215,7 @@
                 </a:solidFill>
                 <a:latin typeface="Arial"/>
               </a:rPr>
-              <a:t>July 13 - July 27</a:t>
+              <a:t>July 13 - August 3</a:t>
             </a:r>
           </a:p>
         </p:txBody>
@@ -3281,7 +3281,7 @@
                 </a:solidFill>
                 <a:latin typeface="Arial"/>
               </a:rPr>
-              <a:t>2,876</a:t>
+              <a:t>4,395</a:t>
             </a:r>
           </a:p>
         </p:txBody>
@@ -3347,7 +3347,7 @@
                 </a:solidFill>
                 <a:latin typeface="Arial"/>
               </a:rPr>
-              <a:t>161</a:t>
+              <a:t>214</a:t>
             </a:r>
           </a:p>
         </p:txBody>
@@ -3413,7 +3413,7 @@
                 </a:solidFill>
                 <a:latin typeface="Arial"/>
               </a:rPr>
-              <a:t>2,715</a:t>
+              <a:t>4,181</a:t>
             </a:r>
           </a:p>
         </p:txBody>

</xml_diff>